<commit_message>
Added Heatmap exploration, added Item and House memory
</commit_message>
<xml_diff>
--- a/GPP_ZombieAI_OlivierStan_2DAE20.pptx
+++ b/GPP_ZombieAI_OlivierStan_2DAE20.pptx
@@ -11,7 +11,6 @@
     <p:sldId id="258" r:id="rId8"/>
     <p:sldId id="259" r:id="rId9"/>
     <p:sldId id="262" r:id="rId10"/>
-    <p:sldId id="261" r:id="rId11"/>
   </p:sldIdLst>
   <p:sldSz cx="12192000" cy="6858000"/>
   <p:notesSz cx="6858000" cy="9144000"/>
@@ -405,7 +404,7 @@
           <a:p>
             <a:fld id="{82085877-2B37-48E7-8B6D-4D4ED486130A}" type="datetimeFigureOut">
               <a:rPr lang="en-BE" smtClean="0"/>
-              <a:t>11/28/2023</a:t>
+              <a:t>06/04/2026</a:t>
             </a:fld>
             <a:endParaRPr lang="en-BE"/>
           </a:p>
@@ -605,7 +604,7 @@
           <a:p>
             <a:fld id="{82085877-2B37-48E7-8B6D-4D4ED486130A}" type="datetimeFigureOut">
               <a:rPr lang="en-BE" smtClean="0"/>
-              <a:t>11/28/2023</a:t>
+              <a:t>06/04/2026</a:t>
             </a:fld>
             <a:endParaRPr lang="en-BE"/>
           </a:p>
@@ -815,7 +814,7 @@
           <a:p>
             <a:fld id="{82085877-2B37-48E7-8B6D-4D4ED486130A}" type="datetimeFigureOut">
               <a:rPr lang="en-BE" smtClean="0"/>
-              <a:t>11/28/2023</a:t>
+              <a:t>06/04/2026</a:t>
             </a:fld>
             <a:endParaRPr lang="en-BE"/>
           </a:p>
@@ -1015,7 +1014,7 @@
           <a:p>
             <a:fld id="{82085877-2B37-48E7-8B6D-4D4ED486130A}" type="datetimeFigureOut">
               <a:rPr lang="en-BE" smtClean="0"/>
-              <a:t>11/28/2023</a:t>
+              <a:t>06/04/2026</a:t>
             </a:fld>
             <a:endParaRPr lang="en-BE"/>
           </a:p>
@@ -1291,7 +1290,7 @@
           <a:p>
             <a:fld id="{82085877-2B37-48E7-8B6D-4D4ED486130A}" type="datetimeFigureOut">
               <a:rPr lang="en-BE" smtClean="0"/>
-              <a:t>11/28/2023</a:t>
+              <a:t>06/04/2026</a:t>
             </a:fld>
             <a:endParaRPr lang="en-BE"/>
           </a:p>
@@ -1559,7 +1558,7 @@
           <a:p>
             <a:fld id="{82085877-2B37-48E7-8B6D-4D4ED486130A}" type="datetimeFigureOut">
               <a:rPr lang="en-BE" smtClean="0"/>
-              <a:t>11/28/2023</a:t>
+              <a:t>06/04/2026</a:t>
             </a:fld>
             <a:endParaRPr lang="en-BE"/>
           </a:p>
@@ -1974,7 +1973,7 @@
           <a:p>
             <a:fld id="{82085877-2B37-48E7-8B6D-4D4ED486130A}" type="datetimeFigureOut">
               <a:rPr lang="en-BE" smtClean="0"/>
-              <a:t>11/28/2023</a:t>
+              <a:t>06/04/2026</a:t>
             </a:fld>
             <a:endParaRPr lang="en-BE"/>
           </a:p>
@@ -2116,7 +2115,7 @@
           <a:p>
             <a:fld id="{82085877-2B37-48E7-8B6D-4D4ED486130A}" type="datetimeFigureOut">
               <a:rPr lang="en-BE" smtClean="0"/>
-              <a:t>11/28/2023</a:t>
+              <a:t>06/04/2026</a:t>
             </a:fld>
             <a:endParaRPr lang="en-BE"/>
           </a:p>
@@ -2229,7 +2228,7 @@
           <a:p>
             <a:fld id="{82085877-2B37-48E7-8B6D-4D4ED486130A}" type="datetimeFigureOut">
               <a:rPr lang="en-BE" smtClean="0"/>
-              <a:t>11/28/2023</a:t>
+              <a:t>06/04/2026</a:t>
             </a:fld>
             <a:endParaRPr lang="en-BE"/>
           </a:p>
@@ -2542,7 +2541,7 @@
           <a:p>
             <a:fld id="{82085877-2B37-48E7-8B6D-4D4ED486130A}" type="datetimeFigureOut">
               <a:rPr lang="en-BE" smtClean="0"/>
-              <a:t>11/28/2023</a:t>
+              <a:t>06/04/2026</a:t>
             </a:fld>
             <a:endParaRPr lang="en-BE"/>
           </a:p>
@@ -2831,7 +2830,7 @@
           <a:p>
             <a:fld id="{82085877-2B37-48E7-8B6D-4D4ED486130A}" type="datetimeFigureOut">
               <a:rPr lang="en-BE" smtClean="0"/>
-              <a:t>11/28/2023</a:t>
+              <a:t>06/04/2026</a:t>
             </a:fld>
             <a:endParaRPr lang="en-BE"/>
           </a:p>
@@ -3074,7 +3073,7 @@
           <a:p>
             <a:fld id="{82085877-2B37-48E7-8B6D-4D4ED486130A}" type="datetimeFigureOut">
               <a:rPr lang="en-BE" smtClean="0"/>
-              <a:t>11/28/2023</a:t>
+              <a:t>06/04/2026</a:t>
             </a:fld>
             <a:endParaRPr lang="en-BE"/>
           </a:p>
@@ -4136,109 +4135,6 @@
 </p:sld>
 </file>
 
-<file path=ppt/slides/slide7.xml><?xml version="1.0" encoding="utf-8"?>
-<p:sld xmlns:a="http://schemas.openxmlformats.org/drawingml/2006/main" xmlns:r="http://schemas.openxmlformats.org/officeDocument/2006/relationships" xmlns:p="http://schemas.openxmlformats.org/presentationml/2006/main">
-  <p:cSld>
-    <p:spTree>
-      <p:nvGrpSpPr>
-        <p:cNvPr id="1" name=""/>
-        <p:cNvGrpSpPr/>
-        <p:nvPr/>
-      </p:nvGrpSpPr>
-      <p:grpSpPr>
-        <a:xfrm>
-          <a:off x="0" y="0"/>
-          <a:ext cx="0" cy="0"/>
-          <a:chOff x="0" y="0"/>
-          <a:chExt cx="0" cy="0"/>
-        </a:xfrm>
-      </p:grpSpPr>
-      <p:sp>
-        <p:nvSpPr>
-          <p:cNvPr id="2" name="Title 1">
-            <a:extLst>
-              <a:ext uri="{FF2B5EF4-FFF2-40B4-BE49-F238E27FC236}">
-                <a16:creationId xmlns:a16="http://schemas.microsoft.com/office/drawing/2014/main" id="{EF6BB071-C63E-40D3-93C6-9F99F27862FE}"/>
-              </a:ext>
-            </a:extLst>
-          </p:cNvPr>
-          <p:cNvSpPr>
-            <a:spLocks noGrp="1"/>
-          </p:cNvSpPr>
-          <p:nvPr>
-            <p:ph type="title"/>
-          </p:nvPr>
-        </p:nvSpPr>
-        <p:spPr/>
-        <p:txBody>
-          <a:bodyPr/>
-          <a:lstStyle/>
-          <a:p>
-            <a:r>
-              <a:rPr lang="en-US"/>
-              <a:t>High Score</a:t>
-            </a:r>
-            <a:endParaRPr lang="en-BE"/>
-          </a:p>
-        </p:txBody>
-      </p:sp>
-      <p:sp>
-        <p:nvSpPr>
-          <p:cNvPr id="3" name="Content Placeholder 2">
-            <a:extLst>
-              <a:ext uri="{FF2B5EF4-FFF2-40B4-BE49-F238E27FC236}">
-                <a16:creationId xmlns:a16="http://schemas.microsoft.com/office/drawing/2014/main" id="{64915428-ACD8-4B22-96DC-2806680ED3AB}"/>
-              </a:ext>
-            </a:extLst>
-          </p:cNvPr>
-          <p:cNvSpPr>
-            <a:spLocks noGrp="1"/>
-          </p:cNvSpPr>
-          <p:nvPr>
-            <p:ph idx="1"/>
-          </p:nvPr>
-        </p:nvSpPr>
-        <p:spPr/>
-        <p:txBody>
-          <a:bodyPr/>
-          <a:lstStyle/>
-          <a:p>
-            <a:pPr marL="0" indent="0">
-              <a:buNone/>
-            </a:pPr>
-            <a:r>
-              <a:rPr lang="en-US">
-                <a:solidFill>
-                  <a:schemeClr val="bg1">
-                    <a:lumMod val="75000"/>
-                  </a:schemeClr>
-                </a:solidFill>
-              </a:rPr>
-              <a:t>Screen shot or list of highest scores</a:t>
-            </a:r>
-            <a:endParaRPr lang="en-BE">
-              <a:solidFill>
-                <a:schemeClr val="bg1">
-                  <a:lumMod val="75000"/>
-                </a:schemeClr>
-              </a:solidFill>
-            </a:endParaRPr>
-          </a:p>
-        </p:txBody>
-      </p:sp>
-    </p:spTree>
-    <p:extLst>
-      <p:ext uri="{BB962C8B-B14F-4D97-AF65-F5344CB8AC3E}">
-        <p14:creationId xmlns:p14="http://schemas.microsoft.com/office/powerpoint/2010/main" val="3423734040"/>
-      </p:ext>
-    </p:extLst>
-  </p:cSld>
-  <p:clrMapOvr>
-    <a:masterClrMapping/>
-  </p:clrMapOvr>
-</p:sld>
-</file>
-
 <file path=ppt/theme/theme1.xml><?xml version="1.0" encoding="utf-8"?>
 <a:theme xmlns:a="http://schemas.openxmlformats.org/drawingml/2006/main" name="Office Theme">
   <a:themeElements>
@@ -4544,6 +4440,21 @@
 </file>
 
 <file path=customXml/item2.xml><?xml version="1.0" encoding="utf-8"?>
+<p:properties xmlns:p="http://schemas.microsoft.com/office/2006/metadata/properties" xmlns:xsi="http://www.w3.org/2001/XMLSchema-instance" xmlns:pc="http://schemas.microsoft.com/office/infopath/2007/PartnerControls">
+  <documentManagement>
+    <IconOverlay xmlns="http://schemas.microsoft.com/sharepoint/v4" xsi:nil="true"/>
+    <TaxCatchAll xmlns="128482ec-0431-40d5-ab26-89ea2a4f3ccd" xsi:nil="true"/>
+    <m99485b88215436a82099f8287cba0b0 xmlns="128482ec-0431-40d5-ab26-89ea2a4f3ccd">
+      <Terms xmlns="http://schemas.microsoft.com/office/infopath/2007/PartnerControls"/>
+    </m99485b88215436a82099f8287cba0b0>
+    <lcf76f155ced4ddcb4097134ff3c332f xmlns="60eb0cf4-ae2a-4762-800a-cb593b869ecb">
+      <Terms xmlns="http://schemas.microsoft.com/office/infopath/2007/PartnerControls"/>
+    </lcf76f155ced4ddcb4097134ff3c332f>
+  </documentManagement>
+</p:properties>
+</file>
+
+<file path=customXml/item3.xml><?xml version="1.0" encoding="utf-8"?>
 <ct:contentTypeSchema xmlns:ct="http://schemas.microsoft.com/office/2006/metadata/contentType" xmlns:ma="http://schemas.microsoft.com/office/2006/metadata/properties/metaAttributes" ct:_="" ma:_="" ma:contentTypeName="Document" ma:contentTypeID="0x010100723942CCEB3A674D8F1F6472CCEFB38E" ma:contentTypeVersion="11" ma:contentTypeDescription="Create a new document." ma:contentTypeScope="" ma:versionID="e4de40d148e029d40e3aaddc8bf68a5e">
   <xsd:schema xmlns:xsd="http://www.w3.org/2001/XMLSchema" xmlns:xs="http://www.w3.org/2001/XMLSchema" xmlns:p="http://schemas.microsoft.com/office/2006/metadata/properties" xmlns:ns2="128482ec-0431-40d5-ab26-89ea2a4f3ccd" xmlns:ns3="60eb0cf4-ae2a-4762-800a-cb593b869ecb" xmlns:ns4="http://schemas.microsoft.com/sharepoint/v4" xmlns:ns5="a2e691a9-fcfc-4d85-a390-1894fe98bd9e" targetNamespace="http://schemas.microsoft.com/office/2006/metadata/properties" ma:root="true" ma:fieldsID="fce8e8bd091658f3fe51b22d57dec109" ns2:_="" ns3:_="" ns4:_="" ns5:_="">
     <xsd:import namespace="128482ec-0431-40d5-ab26-89ea2a4f3ccd"/>
@@ -4816,21 +4727,6 @@
 </ct:contentTypeSchema>
 </file>
 
-<file path=customXml/item3.xml><?xml version="1.0" encoding="utf-8"?>
-<p:properties xmlns:p="http://schemas.microsoft.com/office/2006/metadata/properties" xmlns:xsi="http://www.w3.org/2001/XMLSchema-instance" xmlns:pc="http://schemas.microsoft.com/office/infopath/2007/PartnerControls">
-  <documentManagement>
-    <IconOverlay xmlns="http://schemas.microsoft.com/sharepoint/v4" xsi:nil="true"/>
-    <TaxCatchAll xmlns="128482ec-0431-40d5-ab26-89ea2a4f3ccd" xsi:nil="true"/>
-    <m99485b88215436a82099f8287cba0b0 xmlns="128482ec-0431-40d5-ab26-89ea2a4f3ccd">
-      <Terms xmlns="http://schemas.microsoft.com/office/infopath/2007/PartnerControls"/>
-    </m99485b88215436a82099f8287cba0b0>
-    <lcf76f155ced4ddcb4097134ff3c332f xmlns="60eb0cf4-ae2a-4762-800a-cb593b869ecb">
-      <Terms xmlns="http://schemas.microsoft.com/office/infopath/2007/PartnerControls"/>
-    </lcf76f155ced4ddcb4097134ff3c332f>
-  </documentManagement>
-</p:properties>
-</file>
-
 <file path=customXml/itemProps1.xml><?xml version="1.0" encoding="utf-8"?>
 <ds:datastoreItem xmlns:ds="http://schemas.openxmlformats.org/officeDocument/2006/customXml" ds:itemID="{AF8EC6D1-CB19-4400-AD0A-0C75CD884AEA}">
   <ds:schemaRefs>
@@ -4840,6 +4736,18 @@
 </file>
 
 <file path=customXml/itemProps2.xml><?xml version="1.0" encoding="utf-8"?>
+<ds:datastoreItem xmlns:ds="http://schemas.openxmlformats.org/officeDocument/2006/customXml" ds:itemID="{B743389A-7EE0-4951-8919-E91DD69E3687}">
+  <ds:schemaRefs>
+    <ds:schemaRef ds:uri="128482ec-0431-40d5-ab26-89ea2a4f3ccd"/>
+    <ds:schemaRef ds:uri="http://schemas.microsoft.com/office/2006/metadata/properties"/>
+    <ds:schemaRef ds:uri="http://schemas.microsoft.com/office/infopath/2007/PartnerControls"/>
+    <ds:schemaRef ds:uri="http://schemas.microsoft.com/sharepoint/v4"/>
+    <ds:schemaRef ds:uri="60eb0cf4-ae2a-4762-800a-cb593b869ecb"/>
+  </ds:schemaRefs>
+</ds:datastoreItem>
+</file>
+
+<file path=customXml/itemProps3.xml><?xml version="1.0" encoding="utf-8"?>
 <ds:datastoreItem xmlns:ds="http://schemas.openxmlformats.org/officeDocument/2006/customXml" ds:itemID="{D7B8C5DE-3345-4025-A942-C5AA68E55545}">
   <ds:schemaRefs>
     <ds:schemaRef ds:uri="http://schemas.microsoft.com/office/2006/metadata/contentType"/>
@@ -4858,16 +4766,4 @@
     <ds:schemaRef ds:uri="http://schemas.microsoft.com/internal/obd"/>
   </ds:schemaRefs>
 </ds:datastoreItem>
-</file>
-
-<file path=customXml/itemProps3.xml><?xml version="1.0" encoding="utf-8"?>
-<ds:datastoreItem xmlns:ds="http://schemas.openxmlformats.org/officeDocument/2006/customXml" ds:itemID="{B743389A-7EE0-4951-8919-E91DD69E3687}">
-  <ds:schemaRefs>
-    <ds:schemaRef ds:uri="128482ec-0431-40d5-ab26-89ea2a4f3ccd"/>
-    <ds:schemaRef ds:uri="http://schemas.microsoft.com/office/2006/metadata/properties"/>
-    <ds:schemaRef ds:uri="http://schemas.microsoft.com/office/infopath/2007/PartnerControls"/>
-    <ds:schemaRef ds:uri="http://schemas.microsoft.com/sharepoint/v4"/>
-    <ds:schemaRef ds:uri="60eb0cf4-ae2a-4762-800a-cb593b869ecb"/>
-  </ds:schemaRefs>
-</ds:datastoreItem>
 </file>
</xml_diff>